<commit_message>
Publish scratch thesis pitch site
</commit_message>
<xml_diff>
--- a/artifacts/output/doc/defense_presentation.pptx
+++ b/artifacts/output/doc/defense_presentation.pptx
@@ -7855,7 +7855,7 @@
       </p:sp>
       <p:pic>
         <p:nvPicPr>
-          <p:cNvPr id="15" name="Image 0" descr="D:\LSD_Thesis\output\doc\figures\stage1_metric_shift.png">    </p:cNvPr>
+          <p:cNvPr id="15" name="Image 0" descr="D:\LSD_Thesis\.worktrees\scratch-thesis-site\output\doc\figures\stage1_metric_shift.png">    </p:cNvPr>
           <p:cNvPicPr>
             <a:picLocks noChangeAspect="1"/>
           </p:cNvPicPr>
@@ -8414,7 +8414,7 @@
       </p:sp>
       <p:pic>
         <p:nvPicPr>
-          <p:cNvPr id="15" name="Image 0" descr="D:\LSD_Thesis\output\doc\figures\stage2_fit_robustness.png">    </p:cNvPr>
+          <p:cNvPr id="15" name="Image 0" descr="D:\LSD_Thesis\.worktrees\scratch-thesis-site\output\doc\figures\stage2_fit_robustness.png">    </p:cNvPr>
           <p:cNvPicPr>
             <a:picLocks noChangeAspect="1"/>
           </p:cNvPicPr>

</xml_diff>

<commit_message>
Publish self explanatory thesis site
</commit_message>
<xml_diff>
--- a/artifacts/output/doc/defense_presentation.pptx
+++ b/artifacts/output/doc/defense_presentation.pptx
@@ -7855,7 +7855,7 @@
       </p:sp>
       <p:pic>
         <p:nvPicPr>
-          <p:cNvPr id="15" name="Image 0" descr="D:\LSD_Thesis\.worktrees\scratch-thesis-site\output\doc\figures\stage1_metric_shift.png">    </p:cNvPr>
+          <p:cNvPr id="15" name="Image 0" descr="D:\LSD_Thesis\.worktrees\main-source-publish\output\doc\figures\stage1_metric_shift.png">    </p:cNvPr>
           <p:cNvPicPr>
             <a:picLocks noChangeAspect="1"/>
           </p:cNvPicPr>
@@ -8414,7 +8414,7 @@
       </p:sp>
       <p:pic>
         <p:nvPicPr>
-          <p:cNvPr id="15" name="Image 0" descr="D:\LSD_Thesis\.worktrees\scratch-thesis-site\output\doc\figures\stage2_fit_robustness.png">    </p:cNvPr>
+          <p:cNvPr id="15" name="Image 0" descr="D:\LSD_Thesis\.worktrees\main-source-publish\output\doc\figures\stage2_fit_robustness.png">    </p:cNvPr>
           <p:cNvPicPr>
             <a:picLocks noChangeAspect="1"/>
           </p:cNvPicPr>

</xml_diff>

<commit_message>
Publish refreshed thesis evidence snapshot
</commit_message>
<xml_diff>
--- a/artifacts/output/doc/defense_presentation.pptx
+++ b/artifacts/output/doc/defense_presentation.pptx
@@ -7855,7 +7855,7 @@
       </p:sp>
       <p:pic>
         <p:nvPicPr>
-          <p:cNvPr id="15" name="Image 0" descr="D:\LSD_Thesis\.worktrees\main-source-publish\output\doc\figures\stage1_metric_shift.png">    </p:cNvPr>
+          <p:cNvPr id="15" name="Image 0" descr="D:\LSD_Thesis\output\doc\figures\stage1_metric_shift.png">    </p:cNvPr>
           <p:cNvPicPr>
             <a:picLocks noChangeAspect="1"/>
           </p:cNvPicPr>
@@ -8414,7 +8414,7 @@
       </p:sp>
       <p:pic>
         <p:nvPicPr>
-          <p:cNvPr id="15" name="Image 0" descr="D:\LSD_Thesis\.worktrees\main-source-publish\output\doc\figures\stage2_fit_robustness.png">    </p:cNvPr>
+          <p:cNvPr id="15" name="Image 0" descr="D:\LSD_Thesis\output\doc\figures\stage2_fit_robustness.png">    </p:cNvPr>
           <p:cNvPicPr>
             <a:picLocks noChangeAspect="1"/>
           </p:cNvPicPr>

</xml_diff>